<commit_message>
build(slides): regenerate pptx from fixed build_deck.js
node build_deck.js exits 0 against the current results/ (full-3,814
validation + P2.2 stats), so the rebuilt deck matches the N1-N3 wording
and data-read fixes.

Co-Authored-By: Claude Opus 5.5 <noreply@anthropic.com>
</commit_message>
<xml_diff>
--- a/slides/CS116_T11_Slide_BaoCao.pptx
+++ b/slides/CS116_T11_Slide_BaoCao.pptx
@@ -26,9 +26,10 @@
     <p:sldId id="274" r:id="rId20"/>
     <p:sldId id="275" r:id="rId21"/>
     <p:sldId id="276" r:id="rId22"/>
+    <p:sldId id="277" r:id="rId23"/>
   </p:sldIdLst>
   <p:notesMasterIdLst>
-    <p:notesMasterId r:id="rId23"/>
+    <p:notesMasterId r:id="rId24"/>
   </p:notesMasterIdLst>
   <p:sldSz cx="12192000" cy="6858000"/>
   <p:notesSz cx="6858000" cy="12192000"/>
@@ -213,16 +214,16 @@
                 <c:formatCode>General</c:formatCode>
                 <c:ptCount val="4"/>
                 <c:pt idx="0">
-                  <c:v>0.8</c:v>
+                  <c:v>1.0488</c:v>
                 </c:pt>
                 <c:pt idx="1">
-                  <c:v>27.8</c:v>
+                  <c:v>31.9874</c:v>
                 </c:pt>
                 <c:pt idx="2">
-                  <c:v>40.6</c:v>
+                  <c:v>39.2239</c:v>
                 </c:pt>
                 <c:pt idx="3">
-                  <c:v>50.8</c:v>
+                  <c:v>48.9512</c:v>
                 </c:pt>
               </c:numCache>
             </c:numRef>
@@ -302,16 +303,16 @@
                 <c:formatCode>General</c:formatCode>
                 <c:ptCount val="4"/>
                 <c:pt idx="0">
-                  <c:v>23.0943</c:v>
+                  <c:v>22.1096</c:v>
                 </c:pt>
                 <c:pt idx="1">
-                  <c:v>31.3059</c:v>
+                  <c:v>34.663</c:v>
                 </c:pt>
                 <c:pt idx="2">
-                  <c:v>56.8429</c:v>
+                  <c:v>54.2369</c:v>
                 </c:pt>
                 <c:pt idx="3">
-                  <c:v>59.4886</c:v>
+                  <c:v>57.9782</c:v>
                 </c:pt>
               </c:numCache>
             </c:numRef>
@@ -569,16 +570,16 @@
                 <c:formatCode>General</c:formatCode>
                 <c:ptCount val="4"/>
                 <c:pt idx="0">
-                  <c:v>1.108</c:v>
+                  <c:v>1.5077</c:v>
                 </c:pt>
                 <c:pt idx="1">
-                  <c:v>6.9252</c:v>
+                  <c:v>8.2925</c:v>
                 </c:pt>
                 <c:pt idx="2">
-                  <c:v>45.7064</c:v>
+                  <c:v>43.1964</c:v>
                 </c:pt>
                 <c:pt idx="3">
-                  <c:v>54.5706</c:v>
+                  <c:v>50.6973</c:v>
                 </c:pt>
               </c:numCache>
             </c:numRef>
@@ -661,13 +662,13 @@
                   <c:v>0</c:v>
                 </c:pt>
                 <c:pt idx="1">
-                  <c:v>82.0144</c:v>
+                  <c:v>86.1326</c:v>
                 </c:pt>
                 <c:pt idx="2">
-                  <c:v>27.3381</c:v>
+                  <c:v>30.1464</c:v>
                 </c:pt>
                 <c:pt idx="3">
-                  <c:v>41.0072</c:v>
+                  <c:v>44.9612</c:v>
                 </c:pt>
               </c:numCache>
             </c:numRef>
@@ -2026,7 +2027,7 @@
           <a:p>
             <a:r>
               <a:rPr lang="en-US" dirty="0"/>
-              <a:t>[14:05–15:20] ViSoBERT — mô hình THAY THẾ cho PhoBERT — đạt EM tổng 27,80, và con số đó bằng ĐÚNG tỉ lệ câu không có đáp án của mẫu. Đó không phải trùng hợp: bóc tách ra thì impossible EM là 82 nhưng answerable EM chỉ gần 7 — nó gần như chỉ ăn điểm từ việc từ chối trả lời. Dấu hiệu đã xuất hiện ngay từ epoch 1 trên đường cong huấn luyện. Khi rà lại bằng chứng, bọn em thấy bốn yếu tố đã ĐỦ để giải thích sự suy sụp. Yếu tố mạnh nhất: max_length để nguyên 384, đặt theo tokenizer mBERT. Với tokenizer ViSoBERT thì 154 trên 557 đoạn văn vượt ngân sách, so với 16 của mBERT — gấp gần mười lần. Đây là chỗ dễ nói lẫn nhất nên em nói rõ: độ dài ĐÁP ÁN thì bọn em đã bù, 30 thành 64; trục chưa bù là max_length. Vì vậy báo cáo KHÔNG kết luận rằng tiền huấn luyện tiếng Việt không giúp ích. Con số 27,80 phải đọc như một lần huấn luyện thất bại đã được chẩn đoán, và phép kiểm trực tiếp là huấn luyện lại với max_length lớn hơn.</a:t>
+              <a:t>[14:05–15:20] ViSoBERT — mô hình THAY THẾ cho PhoBERT — đạt EM tổng 31,99, và con số đó bằng ĐÚNG tỉ lệ câu không có đáp án của mẫu. Đó không phải trùng hợp: bóc tách ra thì impossible EM là 82 nhưng answerable EM chỉ gần 7 — nó gần như chỉ ăn điểm từ việc từ chối trả lời. Dấu hiệu đã xuất hiện ngay từ epoch 1 trên đường cong huấn luyện. Khi rà lại bằng chứng, bọn em thấy bốn yếu tố đã ĐỦ để giải thích sự suy sụp. Yếu tố mạnh nhất: max_length để nguyên 384, đặt theo tokenizer mBERT. Với tokenizer ViSoBERT thì 154 trên 557 đoạn văn vượt ngân sách, so với 16 của mBERT — gấp gần mười lần. Đây là chỗ dễ nói lẫn nhất nên em nói rõ: độ dài ĐÁP ÁN thì bọn em đã bù, 30 thành 64; trục chưa bù là max_length. Vì vậy báo cáo KHÔNG kết luận rằng tiền huấn luyện tiếng Việt không giúp ích. Con số 31,99 phải đọc như một lần huấn luyện thất bại đã được chẩn đoán, và phép kiểm trực tiếp là huấn luyện lại với max_length lớn hơn.</a:t>
             </a:r>
             <a:endParaRPr lang="en-US" dirty="0"/>
           </a:p>
@@ -2378,7 +2379,7 @@
           <a:p>
             <a:r>
               <a:rPr lang="en-US" dirty="0"/>
-              <a:t>[17:00–17:45] Tóm lại: bốn mô hình so sánh được trên cùng một interface, mBERT fine-tuned đạt EM 50,80; bộ test nhanh chạy trong một giây; và không số đo nào trong deck này được gõ tay — chúng được đọc từ results khi dựng slide. Phát hiện chính: điểm tổng trộn hai kỹ năng, và bóc tách ra thì mBERT thắng nhờ biết từ chối chứ không nhờ tìm span giỏi hơn. Còn câu hỏi về encoder tiếng Việt thì nhóm em để ngỏ một cách có chủ ý — PhoBERT chưa chạy được vì lý do kỹ thuật, và lần huấn luyện ViSoBERT đã suy sụp vì một nguyên nhân cấu hình bọn em chưa bù trừ. Cảm ơn thầy và các bạn. Nhóm em sẵn sàng nhận câu hỏi.</a:t>
+              <a:t>[17:00–17:45] Tóm lại: bốn mô hình so sánh được trên cùng một interface, mBERT fine-tuned đạt EM 48,95; bộ test nhanh chạy trong một giây; và không số đo nào trong deck này được gõ tay — chúng được đọc từ results khi dựng slide. Phát hiện chính: điểm tổng trộn hai kỹ năng, và bóc tách ra thì mBERT thắng nhờ biết từ chối chứ không nhờ tìm span giỏi hơn. Còn câu hỏi về encoder tiếng Việt thì nhóm em để ngỏ một cách có chủ ý — PhoBERT chưa chạy được vì lý do kỹ thuật, và lần huấn luyện ViSoBERT đã suy sụp vì một nguyên nhân cấu hình bọn em chưa bù trừ. Cảm ơn thầy và các bạn. Nhóm em sẵn sàng nhận câu hỏi.</a:t>
             </a:r>
             <a:endParaRPr lang="en-US" dirty="0"/>
           </a:p>
@@ -2402,6 +2403,94 @@
             <a:fld id="{F7021451-1387-4CA6-816F-3879F97B5CBC}" type="slidenum">
               <a:rPr lang="en-US"/>
               <a:t>21</a:t>
+            </a:fld>
+            <a:endParaRPr lang="en-US"/>
+          </a:p>
+        </p:txBody>
+      </p:sp>
+    </p:spTree>
+    <p:extLst>
+      <p:ext uri="{BB962C8B-B14F-4D97-AF65-F5344CB8AC3E}">
+        <p14:creationId xmlns:p14="http://schemas.microsoft.com/office/powerpoint/2010/main" val="1024086991"/>
+      </p:ext>
+    </p:extLst>
+  </p:cSld>
+  <p:clrMapOvr>
+    <a:masterClrMapping/>
+  </p:clrMapOvr>
+</p:notes>
+</file>
+
+<file path=ppt/notesSlides/notesSlide22.xml><?xml version="1.0" encoding="utf-8"?>
+<p:notes xmlns:a="http://schemas.openxmlformats.org/drawingml/2006/main" xmlns:r="http://schemas.openxmlformats.org/officeDocument/2006/relationships" xmlns:p="http://schemas.openxmlformats.org/presentationml/2006/main">
+  <p:cSld>
+    <p:spTree>
+      <p:nvGrpSpPr>
+        <p:cNvPr id="1" name=""/>
+        <p:cNvGrpSpPr/>
+        <p:nvPr/>
+      </p:nvGrpSpPr>
+      <p:grpSpPr>
+        <a:xfrm>
+          <a:off x="0" y="0"/>
+          <a:ext cx="0" cy="0"/>
+          <a:chOff x="0" y="0"/>
+          <a:chExt cx="0" cy="0"/>
+        </a:xfrm>
+      </p:grpSpPr>
+      <p:sp>
+        <p:nvSpPr>
+          <p:cNvPr id="2" name="Slide Image Placeholder 1"/>
+          <p:cNvSpPr>
+            <a:spLocks noGrp="1" noRot="1" noChangeAspect="1"/>
+          </p:cNvSpPr>
+          <p:nvPr>
+            <p:ph type="sldImg"/>
+          </p:nvPr>
+        </p:nvSpPr>
+        <p:spPr/>
+      </p:sp>
+      <p:sp>
+        <p:nvSpPr>
+          <p:cNvPr id="3" name="Notes Placeholder 2"/>
+          <p:cNvSpPr>
+            <a:spLocks noGrp="1"/>
+          </p:cNvSpPr>
+          <p:nvPr>
+            <p:ph type="body" idx="1"/>
+          </p:nvPr>
+        </p:nvSpPr>
+        <p:spPr/>
+        <p:txBody>
+          <a:bodyPr/>
+          <a:lstStyle/>
+          <a:p>
+            <a:r>
+              <a:rPr lang="en-US" dirty="0"/>
+              <a:t/>
+            </a:r>
+            <a:endParaRPr lang="en-US" dirty="0"/>
+          </a:p>
+        </p:txBody>
+      </p:sp>
+      <p:sp>
+        <p:nvSpPr>
+          <p:cNvPr id="4" name="Slide Number Placeholder 3"/>
+          <p:cNvSpPr>
+            <a:spLocks noGrp="1"/>
+          </p:cNvSpPr>
+          <p:nvPr>
+            <p:ph type="sldNum" sz="quarter" idx="10"/>
+          </p:nvPr>
+        </p:nvSpPr>
+        <p:spPr/>
+        <p:txBody>
+          <a:bodyPr/>
+          <a:lstStyle/>
+          <a:p>
+            <a:fld id="{F7021451-1387-4CA6-816F-3879F97B5CBC}" type="slidenum">
+              <a:rPr lang="en-US"/>
+              <a:t>22</a:t>
             </a:fld>
             <a:endParaRPr lang="en-US"/>
           </a:p>
@@ -3590,7 +3679,7 @@
                 <a:ea typeface="Nunito" pitchFamily="34" charset="-122"/>
                 <a:cs typeface="Nunito" pitchFamily="34" charset="-120"/>
               </a:rPr>
-              <a:t>Bốn mô hình · 500 câu kiểm định · mọi số đo sinh từ results/</a:t>
+              <a:t>Bốn mô hình · 3814 câu kiểm định · mọi số đo sinh từ results/</a:t>
             </a:r>
             <a:endParaRPr lang="en-US" sz="1250" dirty="0"/>
           </a:p>
@@ -8546,7 +8635,7 @@
                 <a:ea typeface="Nunito" pitchFamily="34" charset="-122"/>
                 <a:cs typeface="Nunito" pitchFamily="34" charset="-120"/>
               </a:rPr>
-              <a:t>Bằng chứng: TF-IDF có F1 23,09 nhưng EM chỉ 0,80 — nó trả về cả một câu: trùng token, gần như không bao giờ trùng khít.</a:t>
+              <a:t>Bằng chứng: TF-IDF có F1 22,11 nhưng EM chỉ 1,05 — nó trả về cả một câu: trùng token, gần như không bao giờ trùng khít.</a:t>
             </a:r>
             <a:endParaRPr lang="en-US" sz="1050" dirty="0"/>
           </a:p>
@@ -14412,7 +14501,7 @@
                 <a:ea typeface="Baloo 2" pitchFamily="34" charset="-122"/>
                 <a:cs typeface="Baloo 2" pitchFamily="34" charset="-120"/>
               </a:rPr>
-              <a:t>UIT-ViQuAD 2.0 · validation · n = 500 · thiết bị MPS</a:t>
+              <a:t>UIT-ViQuAD 2.0 · validation · n = 3814 · thiết bị MPS</a:t>
             </a:r>
             <a:endParaRPr lang="en-US" sz="3400" dirty="0"/>
           </a:p>
@@ -14735,7 +14824,7 @@
                           <a:ea typeface="Nunito" pitchFamily="34" charset="-122"/>
                           <a:cs typeface="Nunito" pitchFamily="34" charset="-120"/>
                         </a:rPr>
-                        <a:t>0,80</a:t>
+                        <a:t>1,05</a:t>
                       </a:r>
                       <a:endParaRPr lang="en-US" sz="1250" dirty="0">
                         <a:latin typeface="Nunito" charset="0"/>
@@ -14782,7 +14871,7 @@
                           <a:ea typeface="Nunito" pitchFamily="34" charset="-122"/>
                           <a:cs typeface="Nunito" pitchFamily="34" charset="-120"/>
                         </a:rPr>
-                        <a:t>23,09</a:t>
+                        <a:t>22,11</a:t>
                       </a:r>
                       <a:endParaRPr lang="en-US" sz="1250" dirty="0">
                         <a:latin typeface="Nunito" charset="0"/>
@@ -14829,7 +14918,7 @@
                           <a:ea typeface="Nunito" pitchFamily="34" charset="-122"/>
                           <a:cs typeface="Nunito" pitchFamily="34" charset="-120"/>
                         </a:rPr>
-                        <a:t>0,54 ms</a:t>
+                        <a:t>0,51 ms</a:t>
                       </a:r>
                       <a:endParaRPr lang="en-US" sz="1250" dirty="0">
                         <a:latin typeface="Nunito" charset="0"/>
@@ -14925,7 +15014,7 @@
                           <a:ea typeface="Nunito" pitchFamily="34" charset="-122"/>
                           <a:cs typeface="Nunito" pitchFamily="34" charset="-120"/>
                         </a:rPr>
-                        <a:t>27,80</a:t>
+                        <a:t>31,99</a:t>
                       </a:r>
                       <a:endParaRPr lang="en-US" sz="1250" dirty="0">
                         <a:latin typeface="Nunito" charset="0"/>
@@ -14972,7 +15061,7 @@
                           <a:ea typeface="Nunito" pitchFamily="34" charset="-122"/>
                           <a:cs typeface="Nunito" pitchFamily="34" charset="-120"/>
                         </a:rPr>
-                        <a:t>31,31</a:t>
+                        <a:t>34,66</a:t>
                       </a:r>
                       <a:endParaRPr lang="en-US" sz="1250" dirty="0">
                         <a:latin typeface="Nunito" charset="0"/>
@@ -15019,7 +15108,7 @@
                           <a:ea typeface="Nunito" pitchFamily="34" charset="-122"/>
                           <a:cs typeface="Nunito" pitchFamily="34" charset="-120"/>
                         </a:rPr>
-                        <a:t>22,73 ms</a:t>
+                        <a:t>27,18 ms</a:t>
                       </a:r>
                       <a:endParaRPr lang="en-US" sz="1250" dirty="0">
                         <a:latin typeface="Nunito" charset="0"/>
@@ -15115,7 +15204,7 @@
                           <a:ea typeface="Nunito" pitchFamily="34" charset="-122"/>
                           <a:cs typeface="Nunito" pitchFamily="34" charset="-120"/>
                         </a:rPr>
-                        <a:t>40,60</a:t>
+                        <a:t>39,22</a:t>
                       </a:r>
                       <a:endParaRPr lang="en-US" sz="1250" dirty="0">
                         <a:latin typeface="Nunito" charset="0"/>
@@ -15162,7 +15251,7 @@
                           <a:ea typeface="Nunito" pitchFamily="34" charset="-122"/>
                           <a:cs typeface="Nunito" pitchFamily="34" charset="-120"/>
                         </a:rPr>
-                        <a:t>56,84</a:t>
+                        <a:t>54,24</a:t>
                       </a:r>
                       <a:endParaRPr lang="en-US" sz="1250" dirty="0">
                         <a:latin typeface="Nunito" charset="0"/>
@@ -15209,7 +15298,7 @@
                           <a:ea typeface="Nunito" pitchFamily="34" charset="-122"/>
                           <a:cs typeface="Nunito" pitchFamily="34" charset="-120"/>
                         </a:rPr>
-                        <a:t>14,35 ms</a:t>
+                        <a:t>13,55 ms</a:t>
                       </a:r>
                       <a:endParaRPr lang="en-US" sz="1250" dirty="0">
                         <a:latin typeface="Nunito" charset="0"/>
@@ -15305,7 +15394,7 @@
                           <a:ea typeface="Nunito" pitchFamily="34" charset="-122"/>
                           <a:cs typeface="Nunito" pitchFamily="34" charset="-120"/>
                         </a:rPr>
-                        <a:t>50,80</a:t>
+                        <a:t>48,95</a:t>
                       </a:r>
                       <a:endParaRPr lang="en-US" sz="1250" dirty="0">
                         <a:latin typeface="Nunito" charset="0"/>
@@ -15352,7 +15441,7 @@
                           <a:ea typeface="Nunito" pitchFamily="34" charset="-122"/>
                           <a:cs typeface="Nunito" pitchFamily="34" charset="-120"/>
                         </a:rPr>
-                        <a:t>59,49</a:t>
+                        <a:t>57,98</a:t>
                       </a:r>
                       <a:endParaRPr lang="en-US" sz="1250" dirty="0">
                         <a:latin typeface="Nunito" charset="0"/>
@@ -15399,7 +15488,7 @@
                           <a:ea typeface="Nunito" pitchFamily="34" charset="-122"/>
                           <a:cs typeface="Nunito" pitchFamily="34" charset="-120"/>
                         </a:rPr>
-                        <a:t>12,26 ms</a:t>
+                        <a:t>13,42 ms</a:t>
                       </a:r>
                       <a:endParaRPr lang="en-US" sz="1250" dirty="0">
                         <a:latin typeface="Nunito" charset="0"/>
@@ -15483,7 +15572,7 @@
                 <a:ea typeface="Baloo 2" pitchFamily="34" charset="-122"/>
                 <a:cs typeface="Baloo 2" pitchFamily="34" charset="-120"/>
               </a:rPr>
-              <a:t>50,80</a:t>
+              <a:t>48,95</a:t>
             </a:r>
             <a:pPr indent="0" marL="0">
               <a:buNone/>
@@ -15612,7 +15701,7 @@
                 <a:ea typeface="Nunito" pitchFamily="34" charset="-122"/>
                 <a:cs typeface="Nunito" pitchFamily="34" charset="-120"/>
               </a:rPr>
-              <a:t>khoảng tin cậy 95% của EM ở n = 500</a:t>
+              <a:t>khoảng tin cậy 95% của EM ở n = 3814</a:t>
             </a:r>
             <a:endParaRPr lang="en-US" sz="1150" dirty="0"/>
           </a:p>
@@ -15651,7 +15740,7 @@
                 <a:ea typeface="Baloo 2" pitchFamily="34" charset="-122"/>
                 <a:cs typeface="Baloo 2" pitchFamily="34" charset="-120"/>
               </a:rPr>
-              <a:t>27,80%</a:t>
+              <a:t>30,44%</a:t>
             </a:r>
             <a:pPr indent="0" marL="0">
               <a:buNone/>
@@ -15819,7 +15908,7 @@
                 <a:ea typeface="Nunito" pitchFamily="34" charset="-122"/>
                 <a:cs typeface="Nunito" pitchFamily="34" charset="-120"/>
               </a:rPr>
-              <a:t>5 · Kết quả · results/eval_*.json · commit 590e775, c63b28c</a:t>
+              <a:t>5 · Kết quả · results/eval_*.json · commit c2b00b1, 57b756a</a:t>
             </a:r>
             <a:endParaRPr lang="en-US" sz="1000" dirty="0"/>
           </a:p>
@@ -16102,7 +16191,7 @@
                 <a:ea typeface="Baloo 2" pitchFamily="34" charset="-122"/>
                 <a:cs typeface="Baloo 2" pitchFamily="34" charset="-120"/>
               </a:rPr>
-              <a:t>F1  68,20   so với   66,60</a:t>
+              <a:t>F1  64,78   so với   63,67</a:t>
             </a:r>
             <a:endParaRPr lang="en-US" sz="2200" dirty="0"/>
           </a:p>
@@ -16259,7 +16348,7 @@
                 <a:ea typeface="Baloo 2" pitchFamily="34" charset="-122"/>
                 <a:cs typeface="Baloo 2" pitchFamily="34" charset="-120"/>
               </a:rPr>
-              <a:t>impossible EM  41,01  so với  27,34</a:t>
+              <a:t>impossible EM  44,96  so với  30,15</a:t>
             </a:r>
             <a:endParaRPr lang="en-US" sz="1900" dirty="0"/>
           </a:p>
@@ -16301,7 +16390,7 @@
                 <a:ea typeface="Nunito" pitchFamily="34" charset="-122"/>
                 <a:cs typeface="Nunito" pitchFamily="34" charset="-120"/>
               </a:rPr>
-              <a:t>+13,67 điểm ± 11,03 — có ý nghĩa thống kê. Với 27,80% câu trong mẫu là không có đáp án, chính kỹ năng thứ hai quyết định bảng xếp hạng.</a:t>
+              <a:t>+13,67 điểm ± 11,03 — có ý nghĩa thống kê. Với 30,44% câu trong mẫu là không có đáp án, chính kỹ năng thứ hai quyết định bảng xếp hạng.</a:t>
             </a:r>
             <a:endParaRPr lang="en-US" sz="1150" dirty="0"/>
           </a:p>
@@ -16607,7 +16696,7 @@
                 <a:ea typeface="Baloo 2" pitchFamily="34" charset="-122"/>
                 <a:cs typeface="Baloo 2" pitchFamily="34" charset="-120"/>
               </a:rPr>
-              <a:t>EM tổng  27,80</a:t>
+              <a:t>EM tổng  31,99</a:t>
             </a:r>
             <a:endParaRPr lang="en-US" sz="2300" dirty="0"/>
           </a:p>
@@ -16646,7 +16735,7 @@
                 <a:ea typeface="Baloo 2" pitchFamily="34" charset="-122"/>
                 <a:cs typeface="Baloo 2" pitchFamily="34" charset="-120"/>
               </a:rPr>
-              <a:t>=   tỉ lệ câu không có đáp án của mẫu  27,80%</a:t>
+              <a:t>=   tỉ lệ câu không có đáp án của mẫu  30,44%</a:t>
             </a:r>
             <a:endParaRPr lang="en-US" sz="1700" dirty="0"/>
           </a:p>
@@ -16727,7 +16816,7 @@
                 <a:ea typeface="Baloo 2" pitchFamily="34" charset="-122"/>
                 <a:cs typeface="Baloo 2" pitchFamily="34" charset="-120"/>
               </a:rPr>
-              <a:t>82,01</a:t>
+              <a:t>86,13</a:t>
             </a:r>
             <a:pPr indent="0" marL="0">
               <a:buNone/>
@@ -16831,7 +16920,7 @@
                 <a:ea typeface="Baloo 2" pitchFamily="34" charset="-122"/>
                 <a:cs typeface="Baloo 2" pitchFamily="34" charset="-120"/>
               </a:rPr>
-              <a:t>6,93</a:t>
+              <a:t>8,29</a:t>
             </a:r>
             <a:pPr indent="0" marL="0">
               <a:buNone/>
@@ -17718,8 +17807,8 @@
         </p:nvSpPr>
         <p:spPr>
           <a:xfrm>
-            <a:off x="6281928" y="3401568"/>
-            <a:ext cx="4937760" cy="274320"/>
+            <a:off x="6281928" y="3255264"/>
+            <a:ext cx="4937760" cy="548640"/>
           </a:xfrm>
           <a:prstGeom prst="rect">
             <a:avLst/>
@@ -17733,12 +17822,12 @@
           <a:p>
             <a:pPr algn="l" indent="0" marL="0">
               <a:lnSpc>
-                <a:spcPts val="1595"/>
+                <a:spcPts val="1450"/>
               </a:lnSpc>
               <a:buNone/>
             </a:pPr>
             <a:r>
-              <a:rPr lang="en-US" sz="1100" i="1" dirty="0">
+              <a:rPr lang="en-US" sz="1000" i="1" dirty="0">
                 <a:solidFill>
                   <a:srgbClr val="3D472B"/>
                 </a:solidFill>
@@ -17746,9 +17835,9 @@
                 <a:ea typeface="Nunito" pitchFamily="34" charset="-122"/>
                 <a:cs typeface="Nunito" pitchFamily="34" charset="-120"/>
               </a:rPr>
-              <a:t>Mỗi cửa sổ thêm vào là một cơ hội nữa để điểm “rỗng” thắng.</a:t>
-            </a:r>
-            <a:endParaRPr lang="en-US" sz="1100" dirty="0"/>
+              <a:t>Suy luận trả RỖNG chỉ khi MỌI cửa sổ đều chọn null — cửa sổ nhiều hơn làm GIẢM tỉ lệ rỗng, không phải tăng. Nguyên nhân thật nằm ở HUẤN LUYỆN: 49,30% cửa sổ train của ViSoBERT mang nhãn null, so với 36,16% của mBERT.</a:t>
+            </a:r>
+            <a:endParaRPr lang="en-US" sz="1000" dirty="0"/>
           </a:p>
         </p:txBody>
       </p:sp>
@@ -18029,7 +18118,7 @@
                 <a:ea typeface="Nunito" pitchFamily="34" charset="-122"/>
                 <a:cs typeface="Nunito" pitchFamily="34" charset="-120"/>
               </a:rPr>
-              <a:t>sức chứa nhỏ hơn 45%</a:t>
+              <a:t>KHÔNG phải “sức chứa nhỏ hơn 45%”</a:t>
             </a:r>
             <a:endParaRPr lang="en-US" sz="1150" dirty="0"/>
           </a:p>
@@ -18071,7 +18160,7 @@
                 <a:ea typeface="Nunito" pitchFamily="34" charset="-122"/>
                 <a:cs typeface="Nunito" pitchFamily="34" charset="-120"/>
               </a:rPr>
-              <a:t>97,0 M so với 177,3 M tham số</a:t>
+              <a:t>cùng thân encoder ~85,1 M — khác ở bảng embedding: 91,8 M (mBERT) so với 11,5 M (ViSoBERT)</a:t>
             </a:r>
             <a:endParaRPr lang="en-US" sz="1000" dirty="0"/>
           </a:p>
@@ -18308,7 +18397,7 @@
                 <a:ea typeface="Nunito" pitchFamily="34" charset="-122"/>
                 <a:cs typeface="Nunito" pitchFamily="34" charset="-120"/>
               </a:rPr>
-              <a:t>Từ vựng nhỏ chia vụn văn bản Wikipedia và ngân sách cửa sổ không được chỉnh theo — lời giải thích PHÙ HỢP với bằng chứng, chưa phải nhân quả đã chứng minh. ViSoBERT chưa huấn luyện lại sau chẩn đoán, nên 27,80 EM phải đọc như MỘT LẦN HUẤN LUYỆN THẤT BẠI, không phải một phép đo năng lực encoder.</a:t>
+              <a:t>Từ vựng nhỏ chia vụn văn bản Wikipedia và ngân sách cửa sổ không được chỉnh theo — lời giải thích PHÙ HỢP với bằng chứng, chưa phải nhân quả đã chứng minh. ViSoBERT chưa huấn luyện lại sau chẩn đoán, nên 31,99 EM phải đọc như MỘT LẦN HUẤN LUYỆN THẤT BẠI, không phải một phép đo năng lực encoder.</a:t>
             </a:r>
             <a:endParaRPr lang="en-US" sz="1150" dirty="0"/>
           </a:p>
@@ -22096,7 +22185,7 @@
                 <a:ea typeface="Nunito" pitchFamily="34" charset="-122"/>
                 <a:cs typeface="Nunito" pitchFamily="34" charset="-120"/>
               </a:rPr>
-              <a:t>n = 500, một seed duy nhất</a:t>
+              <a:t>n = 3814, một seed duy nhất</a:t>
             </a:r>
             <a:endParaRPr lang="en-US" sz="1250" dirty="0"/>
           </a:p>
@@ -22295,7 +22384,7 @@
                 <a:ea typeface="Nunito" pitchFamily="34" charset="-122"/>
                 <a:cs typeface="Nunito" pitchFamily="34" charset="-120"/>
               </a:rPr>
-              <a:t>Mẫu chỉ có 9 câu ở nhóm 300+ nên chưa trả lời được; question_type là heuristic tự gán, ngưỡng 0,6 chọn theo quan sát</a:t>
+              <a:t>Mẫu chỉ có 129 câu ở nhóm 300+ nên chưa trả lời được; question_type là heuristic tự gán, ngưỡng 0,6 chọn theo quan sát</a:t>
             </a:r>
             <a:endParaRPr lang="en-US" sz="1050" dirty="0"/>
           </a:p>
@@ -22403,7 +22492,7 @@
                 <a:ea typeface="Nunito" pitchFamily="34" charset="-122"/>
                 <a:cs typeface="Nunito" pitchFamily="34" charset="-120"/>
               </a:rPr>
-              <a:t>Huấn luyện lại ViSoBERT với max_length 768 và lr thấp hơn — phép kiểm trực tiếp  ·  chạy --full trên 3.814 câu  ·  thêm epoch cho mBERT (loss vẫn đang giảm)  ·  tích hợp PhoBERT khi có đường lấy offset  ·  mở rộng dữ liệu ra ngoài miền Wikipedia</a:t>
+              <a:t>Huấn luyện lại ViSoBERT với max_length 512 (giới hạn positional embedding; hoặc giảm cửa sổ null / tăng doc_stride) và lr thấp hơn — phép kiểm trực tiếp  ·  chạy --full trên 3.814 câu  ·  thêm epoch cho mBERT (loss vẫn đang giảm)  ·  tích hợp PhoBERT khi có đường lấy offset  ·  mở rộng dữ liệu ra ngoài miền Wikipedia</a:t>
             </a:r>
             <a:endParaRPr lang="en-US" sz="1100" dirty="0"/>
           </a:p>
@@ -22719,7 +22808,7 @@
                 <a:ea typeface="Baloo 2" pitchFamily="34" charset="-122"/>
                 <a:cs typeface="Baloo 2" pitchFamily="34" charset="-120"/>
               </a:rPr>
-              <a:t>50,80</a:t>
+              <a:t>48,95</a:t>
             </a:r>
             <a:endParaRPr lang="en-US" sz="3000" dirty="0"/>
           </a:p>
@@ -23242,6 +23331,1221 @@
                 <a:cs typeface="Nunito" pitchFamily="34" charset="-120"/>
               </a:rPr>
               <a:t>21</a:t>
+            </a:r>
+            <a:endParaRPr lang="en-US" sz="1000" dirty="0"/>
+          </a:p>
+        </p:txBody>
+      </p:sp>
+    </p:spTree>
+  </p:cSld>
+  <p:clrMapOvr>
+    <a:masterClrMapping/>
+  </p:clrMapOvr>
+</p:sld>
+</file>
+
+<file path=ppt/slides/slide22.xml><?xml version="1.0" encoding="utf-8"?>
+<p:sld xmlns:a="http://schemas.openxmlformats.org/drawingml/2006/main" xmlns:r="http://schemas.openxmlformats.org/officeDocument/2006/relationships" xmlns:p="http://schemas.openxmlformats.org/presentationml/2006/main">
+  <p:cSld name="Slide 22">
+    <p:bg>
+      <p:bgPr>
+        <a:solidFill>
+          <a:srgbClr val="F5EAD8"/>
+        </a:solidFill>
+      </p:bgPr>
+    </p:bg>
+    <p:spTree>
+      <p:nvGrpSpPr>
+        <p:cNvPr id="1" name=""/>
+        <p:cNvGrpSpPr/>
+        <p:nvPr/>
+      </p:nvGrpSpPr>
+      <p:grpSpPr>
+        <a:xfrm>
+          <a:off x="0" y="0"/>
+          <a:ext cx="0" cy="0"/>
+          <a:chOff x="0" y="0"/>
+          <a:chExt cx="0" cy="0"/>
+        </a:xfrm>
+      </p:grpSpPr>
+      <p:sp>
+        <p:nvSpPr>
+          <p:cNvPr id="2" name="Text 0"/>
+          <p:cNvSpPr txBox="1"/>
+          <p:nvPr/>
+        </p:nvSpPr>
+        <p:spPr>
+          <a:xfrm>
+            <a:off x="685800" y="420624"/>
+            <a:ext cx="10820095" cy="256032"/>
+          </a:xfrm>
+          <a:prstGeom prst="rect">
+            <a:avLst/>
+          </a:prstGeom>
+          <a:noFill/>
+          <a:ln/>
+        </p:spPr>
+        <p:txBody>
+          <a:bodyPr wrap="square" lIns="0" tIns="0" rIns="0" bIns="0" rtlCol="0" anchor="ctr"/>
+          <a:lstStyle/>
+          <a:p>
+            <a:pPr indent="0" marL="0">
+              <a:buNone/>
+            </a:pPr>
+            <a:r>
+              <a:rPr lang="en-US" sz="1100" b="1" spc="220" kern="0" dirty="0">
+                <a:solidFill>
+                  <a:srgbClr val="C67139"/>
+                </a:solidFill>
+                <a:latin typeface="Nunito" pitchFamily="34" charset="0"/>
+                <a:ea typeface="Nunito" pitchFamily="34" charset="-122"/>
+                <a:cs typeface="Nunito" pitchFamily="34" charset="-120"/>
+              </a:rPr>
+              <a:t>PHỤ LỤC · THỐNG KÊ TRÊN TOÀN BỘ VALIDATION</a:t>
+            </a:r>
+            <a:endParaRPr lang="en-US" sz="1100" dirty="0"/>
+          </a:p>
+        </p:txBody>
+      </p:sp>
+      <p:sp>
+        <p:nvSpPr>
+          <p:cNvPr id="3" name="Text 1"/>
+          <p:cNvSpPr txBox="1"/>
+          <p:nvPr/>
+        </p:nvSpPr>
+        <p:spPr>
+          <a:xfrm>
+            <a:off x="685800" y="694944"/>
+            <a:ext cx="10820095" cy="713232"/>
+          </a:xfrm>
+          <a:prstGeom prst="rect">
+            <a:avLst/>
+          </a:prstGeom>
+          <a:noFill/>
+          <a:ln/>
+        </p:spPr>
+        <p:txBody>
+          <a:bodyPr wrap="square" lIns="0" tIns="0" rIns="0" bIns="0" rtlCol="0" anchor="t"/>
+          <a:lstStyle/>
+          <a:p>
+            <a:pPr indent="0" marL="0">
+              <a:lnSpc>
+                <a:spcPts val="3808"/>
+              </a:lnSpc>
+              <a:buNone/>
+            </a:pPr>
+            <a:r>
+              <a:rPr lang="en-US" sz="3400" b="1" dirty="0">
+                <a:solidFill>
+                  <a:srgbClr val="201E1D"/>
+                </a:solidFill>
+                <a:latin typeface="Baloo 2" pitchFamily="34" charset="0"/>
+                <a:ea typeface="Baloo 2" pitchFamily="34" charset="-122"/>
+                <a:cs typeface="Baloo 2" pitchFamily="34" charset="-120"/>
+              </a:rPr>
+              <a:t>Khoảng tin cậy Wilson &amp; kiểm định McNemar (n = 3814)</a:t>
+            </a:r>
+            <a:endParaRPr lang="en-US" sz="3400" dirty="0"/>
+          </a:p>
+        </p:txBody>
+      </p:sp>
+      <p:graphicFrame>
+        <p:nvGraphicFramePr>
+          <p:cNvPr id="23" name="Table 0"/>
+          <p:cNvGraphicFramePr>
+            <a:graphicFrameLocks noGrp="1"/>
+          </p:cNvGraphicFramePr>
+          <p:nvPr>
+            <p:extLst>
+              <p:ext uri="{D42A27DB-BD31-4B8C-83A1-F6EECF244321}">
+                <p14:modId xmlns:p14="http://schemas.microsoft.com/office/powerpoint/2010/main" val="1579011935"/>
+              </p:ext>
+            </p:extLst>
+          </p:nvPr>
+        </p:nvGraphicFramePr>
+        <p:xfrm>
+          <a:off x="685800" y="1737360"/>
+          <a:ext cx="5760720" cy="914400"/>
+        </p:xfrm>
+        <a:graphic>
+          <a:graphicData uri="http://schemas.openxmlformats.org/drawingml/2006/table">
+            <a:tbl>
+              <a:tblPr/>
+              <a:tblGrid>
+                <a:gridCol w="1828800"/>
+                <a:gridCol w="1097280"/>
+                <a:gridCol w="1920240"/>
+                <a:gridCol w="914400"/>
+              </a:tblGrid>
+              <a:tr h="329184">
+                <a:tc>
+                  <a:txBody>
+                    <a:bodyPr/>
+                    <a:lstStyle/>
+                    <a:p>
+                      <a:pPr algn="l" indent="0" marL="0">
+                        <a:buNone/>
+                      </a:pPr>
+                      <a:r>
+                        <a:rPr lang="en-US" sz="1000" b="1" spc="120" kern="0" dirty="0">
+                          <a:solidFill>
+                            <a:srgbClr val="645C50"/>
+                          </a:solidFill>
+                          <a:latin typeface="Nunito" pitchFamily="34" charset="0"/>
+                          <a:ea typeface="Nunito" pitchFamily="34" charset="-122"/>
+                          <a:cs typeface="Nunito" pitchFamily="34" charset="-120"/>
+                        </a:rPr>
+                        <a:t>MODEL</a:t>
+                      </a:r>
+                      <a:endParaRPr lang="en-US" sz="1000" dirty="0">
+                        <a:latin typeface="Nunito" charset="0"/>
+                        <a:ea typeface="Nunito" charset="0"/>
+                        <a:cs typeface="Nunito" charset="0"/>
+                      </a:endParaRPr>
+                    </a:p>
+                  </a:txBody>
+                  <a:tcPr marL="0" marR="76200" marT="38100" marB="38100" anchor="b">
+                    <a:lnL w="0" cap="flat" cmpd="sng" algn="ctr">
+                      <a:noFill/>
+                    </a:lnL>
+                    <a:lnR w="0" cap="flat" cmpd="sng" algn="ctr">
+                      <a:noFill/>
+                    </a:lnR>
+                    <a:lnT w="0" cap="flat" cmpd="sng" algn="ctr">
+                      <a:noFill/>
+                    </a:lnT>
+                    <a:lnB w="12700" cap="flat" cmpd="sng" algn="ctr">
+                      <a:solidFill>
+                        <a:srgbClr val="C67139"/>
+                      </a:solidFill>
+                      <a:prstDash val="solid"/>
+                      <a:round/>
+                      <a:headEnd type="none" w="med" len="med"/>
+                      <a:tailEnd type="none" w="med" len="med"/>
+                    </a:lnB>
+                  </a:tcPr>
+                </a:tc>
+                <a:tc>
+                  <a:txBody>
+                    <a:bodyPr/>
+                    <a:lstStyle/>
+                    <a:p>
+                      <a:pPr algn="r" indent="0" marL="0">
+                        <a:buNone/>
+                      </a:pPr>
+                      <a:r>
+                        <a:rPr lang="en-US" sz="1000" b="1" spc="120" kern="0" dirty="0">
+                          <a:solidFill>
+                            <a:srgbClr val="645C50"/>
+                          </a:solidFill>
+                          <a:latin typeface="Nunito" pitchFamily="34" charset="0"/>
+                          <a:ea typeface="Nunito" pitchFamily="34" charset="-122"/>
+                          <a:cs typeface="Nunito" pitchFamily="34" charset="-120"/>
+                        </a:rPr>
+                        <a:t>EM</a:t>
+                      </a:r>
+                      <a:endParaRPr lang="en-US" sz="1000" dirty="0">
+                        <a:latin typeface="Nunito" charset="0"/>
+                        <a:ea typeface="Nunito" charset="0"/>
+                        <a:cs typeface="Nunito" charset="0"/>
+                      </a:endParaRPr>
+                    </a:p>
+                  </a:txBody>
+                  <a:tcPr marL="0" marR="76200" marT="38100" marB="38100" anchor="b">
+                    <a:lnL w="0" cap="flat" cmpd="sng" algn="ctr">
+                      <a:noFill/>
+                    </a:lnL>
+                    <a:lnR w="0" cap="flat" cmpd="sng" algn="ctr">
+                      <a:noFill/>
+                    </a:lnR>
+                    <a:lnT w="0" cap="flat" cmpd="sng" algn="ctr">
+                      <a:noFill/>
+                    </a:lnT>
+                    <a:lnB w="12700" cap="flat" cmpd="sng" algn="ctr">
+                      <a:solidFill>
+                        <a:srgbClr val="C67139"/>
+                      </a:solidFill>
+                      <a:prstDash val="solid"/>
+                      <a:round/>
+                      <a:headEnd type="none" w="med" len="med"/>
+                      <a:tailEnd type="none" w="med" len="med"/>
+                    </a:lnB>
+                  </a:tcPr>
+                </a:tc>
+                <a:tc>
+                  <a:txBody>
+                    <a:bodyPr/>
+                    <a:lstStyle/>
+                    <a:p>
+                      <a:pPr algn="r" indent="0" marL="0">
+                        <a:buNone/>
+                      </a:pPr>
+                      <a:r>
+                        <a:rPr lang="en-US" sz="1000" b="1" spc="120" kern="0" dirty="0">
+                          <a:solidFill>
+                            <a:srgbClr val="645C50"/>
+                          </a:solidFill>
+                          <a:latin typeface="Nunito" pitchFamily="34" charset="0"/>
+                          <a:ea typeface="Nunito" pitchFamily="34" charset="-122"/>
+                          <a:cs typeface="Nunito" pitchFamily="34" charset="-120"/>
+                        </a:rPr>
+                        <a:t>WILSON 95% CI</a:t>
+                      </a:r>
+                      <a:endParaRPr lang="en-US" sz="1000" dirty="0">
+                        <a:latin typeface="Nunito" charset="0"/>
+                        <a:ea typeface="Nunito" charset="0"/>
+                        <a:cs typeface="Nunito" charset="0"/>
+                      </a:endParaRPr>
+                    </a:p>
+                  </a:txBody>
+                  <a:tcPr marL="0" marR="76200" marT="38100" marB="38100" anchor="b">
+                    <a:lnL w="0" cap="flat" cmpd="sng" algn="ctr">
+                      <a:noFill/>
+                    </a:lnL>
+                    <a:lnR w="0" cap="flat" cmpd="sng" algn="ctr">
+                      <a:noFill/>
+                    </a:lnR>
+                    <a:lnT w="0" cap="flat" cmpd="sng" algn="ctr">
+                      <a:noFill/>
+                    </a:lnT>
+                    <a:lnB w="12700" cap="flat" cmpd="sng" algn="ctr">
+                      <a:solidFill>
+                        <a:srgbClr val="C67139"/>
+                      </a:solidFill>
+                      <a:prstDash val="solid"/>
+                      <a:round/>
+                      <a:headEnd type="none" w="med" len="med"/>
+                      <a:tailEnd type="none" w="med" len="med"/>
+                    </a:lnB>
+                  </a:tcPr>
+                </a:tc>
+                <a:tc>
+                  <a:txBody>
+                    <a:bodyPr/>
+                    <a:lstStyle/>
+                    <a:p>
+                      <a:pPr algn="r" indent="0" marL="0">
+                        <a:buNone/>
+                      </a:pPr>
+                      <a:r>
+                        <a:rPr lang="en-US" sz="1000" b="1" spc="120" kern="0" dirty="0">
+                          <a:solidFill>
+                            <a:srgbClr val="645C50"/>
+                          </a:solidFill>
+                          <a:latin typeface="Nunito" pitchFamily="34" charset="0"/>
+                          <a:ea typeface="Nunito" pitchFamily="34" charset="-122"/>
+                          <a:cs typeface="Nunito" pitchFamily="34" charset="-120"/>
+                        </a:rPr>
+                        <a:t>F1</a:t>
+                      </a:r>
+                      <a:endParaRPr lang="en-US" sz="1000" dirty="0">
+                        <a:latin typeface="Nunito" charset="0"/>
+                        <a:ea typeface="Nunito" charset="0"/>
+                        <a:cs typeface="Nunito" charset="0"/>
+                      </a:endParaRPr>
+                    </a:p>
+                  </a:txBody>
+                  <a:tcPr marL="0" marR="76200" marT="38100" marB="38100" anchor="b">
+                    <a:lnL w="0" cap="flat" cmpd="sng" algn="ctr">
+                      <a:noFill/>
+                    </a:lnL>
+                    <a:lnR w="0" cap="flat" cmpd="sng" algn="ctr">
+                      <a:noFill/>
+                    </a:lnR>
+                    <a:lnT w="0" cap="flat" cmpd="sng" algn="ctr">
+                      <a:noFill/>
+                    </a:lnT>
+                    <a:lnB w="12700" cap="flat" cmpd="sng" algn="ctr">
+                      <a:solidFill>
+                        <a:srgbClr val="C67139"/>
+                      </a:solidFill>
+                      <a:prstDash val="solid"/>
+                      <a:round/>
+                      <a:headEnd type="none" w="med" len="med"/>
+                      <a:tailEnd type="none" w="med" len="med"/>
+                    </a:lnB>
+                  </a:tcPr>
+                </a:tc>
+              </a:tr>
+              <a:tr h="329184">
+                <a:tc>
+                  <a:txBody>
+                    <a:bodyPr/>
+                    <a:lstStyle/>
+                    <a:p>
+                      <a:pPr algn="l" indent="0" marL="0">
+                        <a:buNone/>
+                      </a:pPr>
+                      <a:r>
+                        <a:rPr lang="en-US" sz="1250" dirty="0">
+                          <a:solidFill>
+                            <a:srgbClr val="201E1D"/>
+                          </a:solidFill>
+                          <a:latin typeface="Nunito" pitchFamily="34" charset="0"/>
+                          <a:ea typeface="Nunito" pitchFamily="34" charset="-122"/>
+                          <a:cs typeface="Nunito" pitchFamily="34" charset="-120"/>
+                        </a:rPr>
+                        <a:t>baseline</a:t>
+                      </a:r>
+                      <a:endParaRPr lang="en-US" sz="1250" dirty="0">
+                        <a:latin typeface="Nunito" charset="0"/>
+                        <a:ea typeface="Nunito" charset="0"/>
+                        <a:cs typeface="Nunito" charset="0"/>
+                      </a:endParaRPr>
+                    </a:p>
+                  </a:txBody>
+                  <a:tcPr marL="0" marR="76200" marT="38100" marB="38100" anchor="ctr">
+                    <a:lnL w="0" cap="flat" cmpd="sng" algn="ctr">
+                      <a:noFill/>
+                    </a:lnL>
+                    <a:lnR w="0" cap="flat" cmpd="sng" algn="ctr">
+                      <a:noFill/>
+                    </a:lnR>
+                    <a:lnT w="0" cap="flat" cmpd="sng" algn="ctr">
+                      <a:noFill/>
+                    </a:lnT>
+                    <a:lnB w="6350" cap="flat" cmpd="sng" algn="ctr">
+                      <a:solidFill>
+                        <a:srgbClr val="D3C9BA"/>
+                      </a:solidFill>
+                      <a:prstDash val="solid"/>
+                      <a:round/>
+                      <a:headEnd type="none" w="med" len="med"/>
+                      <a:tailEnd type="none" w="med" len="med"/>
+                    </a:lnB>
+                  </a:tcPr>
+                </a:tc>
+                <a:tc>
+                  <a:txBody>
+                    <a:bodyPr/>
+                    <a:lstStyle/>
+                    <a:p>
+                      <a:pPr algn="r" indent="0" marL="0">
+                        <a:buNone/>
+                      </a:pPr>
+                      <a:r>
+                        <a:rPr lang="en-US" sz="1250" dirty="0">
+                          <a:solidFill>
+                            <a:srgbClr val="201E1D"/>
+                          </a:solidFill>
+                          <a:latin typeface="Nunito" pitchFamily="34" charset="0"/>
+                          <a:ea typeface="Nunito" pitchFamily="34" charset="-122"/>
+                          <a:cs typeface="Nunito" pitchFamily="34" charset="-120"/>
+                        </a:rPr>
+                        <a:t>1,05</a:t>
+                      </a:r>
+                      <a:endParaRPr lang="en-US" sz="1250" dirty="0">
+                        <a:latin typeface="Nunito" charset="0"/>
+                        <a:ea typeface="Nunito" charset="0"/>
+                        <a:cs typeface="Nunito" charset="0"/>
+                      </a:endParaRPr>
+                    </a:p>
+                  </a:txBody>
+                  <a:tcPr marL="0" marR="76200" marT="38100" marB="38100" anchor="ctr">
+                    <a:lnL w="0" cap="flat" cmpd="sng" algn="ctr">
+                      <a:noFill/>
+                    </a:lnL>
+                    <a:lnR w="0" cap="flat" cmpd="sng" algn="ctr">
+                      <a:noFill/>
+                    </a:lnR>
+                    <a:lnT w="0" cap="flat" cmpd="sng" algn="ctr">
+                      <a:noFill/>
+                    </a:lnT>
+                    <a:lnB w="6350" cap="flat" cmpd="sng" algn="ctr">
+                      <a:solidFill>
+                        <a:srgbClr val="D3C9BA"/>
+                      </a:solidFill>
+                      <a:prstDash val="solid"/>
+                      <a:round/>
+                      <a:headEnd type="none" w="med" len="med"/>
+                      <a:tailEnd type="none" w="med" len="med"/>
+                    </a:lnB>
+                  </a:tcPr>
+                </a:tc>
+                <a:tc>
+                  <a:txBody>
+                    <a:bodyPr/>
+                    <a:lstStyle/>
+                    <a:p>
+                      <a:pPr algn="r" indent="0" marL="0">
+                        <a:buNone/>
+                      </a:pPr>
+                      <a:r>
+                        <a:rPr lang="en-US" sz="1250" dirty="0">
+                          <a:solidFill>
+                            <a:srgbClr val="201E1D"/>
+                          </a:solidFill>
+                          <a:latin typeface="Nunito" pitchFamily="34" charset="0"/>
+                          <a:ea typeface="Nunito" pitchFamily="34" charset="-122"/>
+                          <a:cs typeface="Nunito" pitchFamily="34" charset="-120"/>
+                        </a:rPr>
+                        <a:t>0,77–1,42</a:t>
+                      </a:r>
+                      <a:endParaRPr lang="en-US" sz="1250" dirty="0">
+                        <a:latin typeface="Nunito" charset="0"/>
+                        <a:ea typeface="Nunito" charset="0"/>
+                        <a:cs typeface="Nunito" charset="0"/>
+                      </a:endParaRPr>
+                    </a:p>
+                  </a:txBody>
+                  <a:tcPr marL="0" marR="76200" marT="38100" marB="38100" anchor="ctr">
+                    <a:lnL w="0" cap="flat" cmpd="sng" algn="ctr">
+                      <a:noFill/>
+                    </a:lnL>
+                    <a:lnR w="0" cap="flat" cmpd="sng" algn="ctr">
+                      <a:noFill/>
+                    </a:lnR>
+                    <a:lnT w="0" cap="flat" cmpd="sng" algn="ctr">
+                      <a:noFill/>
+                    </a:lnT>
+                    <a:lnB w="6350" cap="flat" cmpd="sng" algn="ctr">
+                      <a:solidFill>
+                        <a:srgbClr val="D3C9BA"/>
+                      </a:solidFill>
+                      <a:prstDash val="solid"/>
+                      <a:round/>
+                      <a:headEnd type="none" w="med" len="med"/>
+                      <a:tailEnd type="none" w="med" len="med"/>
+                    </a:lnB>
+                  </a:tcPr>
+                </a:tc>
+                <a:tc>
+                  <a:txBody>
+                    <a:bodyPr/>
+                    <a:lstStyle/>
+                    <a:p>
+                      <a:pPr algn="r" indent="0" marL="0">
+                        <a:buNone/>
+                      </a:pPr>
+                      <a:r>
+                        <a:rPr lang="en-US" sz="1250" dirty="0">
+                          <a:solidFill>
+                            <a:srgbClr val="201E1D"/>
+                          </a:solidFill>
+                          <a:latin typeface="Nunito" pitchFamily="34" charset="0"/>
+                          <a:ea typeface="Nunito" pitchFamily="34" charset="-122"/>
+                          <a:cs typeface="Nunito" pitchFamily="34" charset="-120"/>
+                        </a:rPr>
+                        <a:t>22,11</a:t>
+                      </a:r>
+                      <a:endParaRPr lang="en-US" sz="1250" dirty="0">
+                        <a:latin typeface="Nunito" charset="0"/>
+                        <a:ea typeface="Nunito" charset="0"/>
+                        <a:cs typeface="Nunito" charset="0"/>
+                      </a:endParaRPr>
+                    </a:p>
+                  </a:txBody>
+                  <a:tcPr marL="0" marR="76200" marT="38100" marB="38100" anchor="ctr">
+                    <a:lnL w="0" cap="flat" cmpd="sng" algn="ctr">
+                      <a:noFill/>
+                    </a:lnL>
+                    <a:lnR w="0" cap="flat" cmpd="sng" algn="ctr">
+                      <a:noFill/>
+                    </a:lnR>
+                    <a:lnT w="0" cap="flat" cmpd="sng" algn="ctr">
+                      <a:noFill/>
+                    </a:lnT>
+                    <a:lnB w="6350" cap="flat" cmpd="sng" algn="ctr">
+                      <a:solidFill>
+                        <a:srgbClr val="D3C9BA"/>
+                      </a:solidFill>
+                      <a:prstDash val="solid"/>
+                      <a:round/>
+                      <a:headEnd type="none" w="med" len="med"/>
+                      <a:tailEnd type="none" w="med" len="med"/>
+                    </a:lnB>
+                  </a:tcPr>
+                </a:tc>
+              </a:tr>
+              <a:tr h="329184">
+                <a:tc>
+                  <a:txBody>
+                    <a:bodyPr/>
+                    <a:lstStyle/>
+                    <a:p>
+                      <a:pPr algn="l" indent="0" marL="0">
+                        <a:buNone/>
+                      </a:pPr>
+                      <a:r>
+                        <a:rPr lang="en-US" sz="1250" dirty="0">
+                          <a:solidFill>
+                            <a:srgbClr val="201E1D"/>
+                          </a:solidFill>
+                          <a:latin typeface="Nunito" pitchFamily="34" charset="0"/>
+                          <a:ea typeface="Nunito" pitchFamily="34" charset="-122"/>
+                          <a:cs typeface="Nunito" pitchFamily="34" charset="-120"/>
+                        </a:rPr>
+                        <a:t>xlmr</a:t>
+                      </a:r>
+                      <a:endParaRPr lang="en-US" sz="1250" dirty="0">
+                        <a:latin typeface="Nunito" charset="0"/>
+                        <a:ea typeface="Nunito" charset="0"/>
+                        <a:cs typeface="Nunito" charset="0"/>
+                      </a:endParaRPr>
+                    </a:p>
+                  </a:txBody>
+                  <a:tcPr marL="0" marR="76200" marT="38100" marB="38100" anchor="ctr">
+                    <a:lnL w="0" cap="flat" cmpd="sng" algn="ctr">
+                      <a:noFill/>
+                    </a:lnL>
+                    <a:lnR w="0" cap="flat" cmpd="sng" algn="ctr">
+                      <a:noFill/>
+                    </a:lnR>
+                    <a:lnT w="0" cap="flat" cmpd="sng" algn="ctr">
+                      <a:noFill/>
+                    </a:lnT>
+                    <a:lnB w="6350" cap="flat" cmpd="sng" algn="ctr">
+                      <a:solidFill>
+                        <a:srgbClr val="D3C9BA"/>
+                      </a:solidFill>
+                      <a:prstDash val="solid"/>
+                      <a:round/>
+                      <a:headEnd type="none" w="med" len="med"/>
+                      <a:tailEnd type="none" w="med" len="med"/>
+                    </a:lnB>
+                  </a:tcPr>
+                </a:tc>
+                <a:tc>
+                  <a:txBody>
+                    <a:bodyPr/>
+                    <a:lstStyle/>
+                    <a:p>
+                      <a:pPr algn="r" indent="0" marL="0">
+                        <a:buNone/>
+                      </a:pPr>
+                      <a:r>
+                        <a:rPr lang="en-US" sz="1250" dirty="0">
+                          <a:solidFill>
+                            <a:srgbClr val="201E1D"/>
+                          </a:solidFill>
+                          <a:latin typeface="Nunito" pitchFamily="34" charset="0"/>
+                          <a:ea typeface="Nunito" pitchFamily="34" charset="-122"/>
+                          <a:cs typeface="Nunito" pitchFamily="34" charset="-120"/>
+                        </a:rPr>
+                        <a:t>39,22</a:t>
+                      </a:r>
+                      <a:endParaRPr lang="en-US" sz="1250" dirty="0">
+                        <a:latin typeface="Nunito" charset="0"/>
+                        <a:ea typeface="Nunito" charset="0"/>
+                        <a:cs typeface="Nunito" charset="0"/>
+                      </a:endParaRPr>
+                    </a:p>
+                  </a:txBody>
+                  <a:tcPr marL="0" marR="76200" marT="38100" marB="38100" anchor="ctr">
+                    <a:lnL w="0" cap="flat" cmpd="sng" algn="ctr">
+                      <a:noFill/>
+                    </a:lnL>
+                    <a:lnR w="0" cap="flat" cmpd="sng" algn="ctr">
+                      <a:noFill/>
+                    </a:lnR>
+                    <a:lnT w="0" cap="flat" cmpd="sng" algn="ctr">
+                      <a:noFill/>
+                    </a:lnT>
+                    <a:lnB w="6350" cap="flat" cmpd="sng" algn="ctr">
+                      <a:solidFill>
+                        <a:srgbClr val="D3C9BA"/>
+                      </a:solidFill>
+                      <a:prstDash val="solid"/>
+                      <a:round/>
+                      <a:headEnd type="none" w="med" len="med"/>
+                      <a:tailEnd type="none" w="med" len="med"/>
+                    </a:lnB>
+                  </a:tcPr>
+                </a:tc>
+                <a:tc>
+                  <a:txBody>
+                    <a:bodyPr/>
+                    <a:lstStyle/>
+                    <a:p>
+                      <a:pPr algn="r" indent="0" marL="0">
+                        <a:buNone/>
+                      </a:pPr>
+                      <a:r>
+                        <a:rPr lang="en-US" sz="1250" dirty="0">
+                          <a:solidFill>
+                            <a:srgbClr val="201E1D"/>
+                          </a:solidFill>
+                          <a:latin typeface="Nunito" pitchFamily="34" charset="0"/>
+                          <a:ea typeface="Nunito" pitchFamily="34" charset="-122"/>
+                          <a:cs typeface="Nunito" pitchFamily="34" charset="-120"/>
+                        </a:rPr>
+                        <a:t>37,69–40,78</a:t>
+                      </a:r>
+                      <a:endParaRPr lang="en-US" sz="1250" dirty="0">
+                        <a:latin typeface="Nunito" charset="0"/>
+                        <a:ea typeface="Nunito" charset="0"/>
+                        <a:cs typeface="Nunito" charset="0"/>
+                      </a:endParaRPr>
+                    </a:p>
+                  </a:txBody>
+                  <a:tcPr marL="0" marR="76200" marT="38100" marB="38100" anchor="ctr">
+                    <a:lnL w="0" cap="flat" cmpd="sng" algn="ctr">
+                      <a:noFill/>
+                    </a:lnL>
+                    <a:lnR w="0" cap="flat" cmpd="sng" algn="ctr">
+                      <a:noFill/>
+                    </a:lnR>
+                    <a:lnT w="0" cap="flat" cmpd="sng" algn="ctr">
+                      <a:noFill/>
+                    </a:lnT>
+                    <a:lnB w="6350" cap="flat" cmpd="sng" algn="ctr">
+                      <a:solidFill>
+                        <a:srgbClr val="D3C9BA"/>
+                      </a:solidFill>
+                      <a:prstDash val="solid"/>
+                      <a:round/>
+                      <a:headEnd type="none" w="med" len="med"/>
+                      <a:tailEnd type="none" w="med" len="med"/>
+                    </a:lnB>
+                  </a:tcPr>
+                </a:tc>
+                <a:tc>
+                  <a:txBody>
+                    <a:bodyPr/>
+                    <a:lstStyle/>
+                    <a:p>
+                      <a:pPr algn="r" indent="0" marL="0">
+                        <a:buNone/>
+                      </a:pPr>
+                      <a:r>
+                        <a:rPr lang="en-US" sz="1250" dirty="0">
+                          <a:solidFill>
+                            <a:srgbClr val="201E1D"/>
+                          </a:solidFill>
+                          <a:latin typeface="Nunito" pitchFamily="34" charset="0"/>
+                          <a:ea typeface="Nunito" pitchFamily="34" charset="-122"/>
+                          <a:cs typeface="Nunito" pitchFamily="34" charset="-120"/>
+                        </a:rPr>
+                        <a:t>54,24</a:t>
+                      </a:r>
+                      <a:endParaRPr lang="en-US" sz="1250" dirty="0">
+                        <a:latin typeface="Nunito" charset="0"/>
+                        <a:ea typeface="Nunito" charset="0"/>
+                        <a:cs typeface="Nunito" charset="0"/>
+                      </a:endParaRPr>
+                    </a:p>
+                  </a:txBody>
+                  <a:tcPr marL="0" marR="76200" marT="38100" marB="38100" anchor="ctr">
+                    <a:lnL w="0" cap="flat" cmpd="sng" algn="ctr">
+                      <a:noFill/>
+                    </a:lnL>
+                    <a:lnR w="0" cap="flat" cmpd="sng" algn="ctr">
+                      <a:noFill/>
+                    </a:lnR>
+                    <a:lnT w="0" cap="flat" cmpd="sng" algn="ctr">
+                      <a:noFill/>
+                    </a:lnT>
+                    <a:lnB w="6350" cap="flat" cmpd="sng" algn="ctr">
+                      <a:solidFill>
+                        <a:srgbClr val="D3C9BA"/>
+                      </a:solidFill>
+                      <a:prstDash val="solid"/>
+                      <a:round/>
+                      <a:headEnd type="none" w="med" len="med"/>
+                      <a:tailEnd type="none" w="med" len="med"/>
+                    </a:lnB>
+                  </a:tcPr>
+                </a:tc>
+              </a:tr>
+              <a:tr h="329184">
+                <a:tc>
+                  <a:txBody>
+                    <a:bodyPr/>
+                    <a:lstStyle/>
+                    <a:p>
+                      <a:pPr algn="l" indent="0" marL="0">
+                        <a:buNone/>
+                      </a:pPr>
+                      <a:r>
+                        <a:rPr lang="en-US" sz="1250" dirty="0">
+                          <a:solidFill>
+                            <a:srgbClr val="201E1D"/>
+                          </a:solidFill>
+                          <a:latin typeface="Nunito" pitchFamily="34" charset="0"/>
+                          <a:ea typeface="Nunito" pitchFamily="34" charset="-122"/>
+                          <a:cs typeface="Nunito" pitchFamily="34" charset="-120"/>
+                        </a:rPr>
+                        <a:t>visobert</a:t>
+                      </a:r>
+                      <a:endParaRPr lang="en-US" sz="1250" dirty="0">
+                        <a:latin typeface="Nunito" charset="0"/>
+                        <a:ea typeface="Nunito" charset="0"/>
+                        <a:cs typeface="Nunito" charset="0"/>
+                      </a:endParaRPr>
+                    </a:p>
+                  </a:txBody>
+                  <a:tcPr marL="0" marR="76200" marT="38100" marB="38100" anchor="ctr">
+                    <a:lnL w="0" cap="flat" cmpd="sng" algn="ctr">
+                      <a:noFill/>
+                    </a:lnL>
+                    <a:lnR w="0" cap="flat" cmpd="sng" algn="ctr">
+                      <a:noFill/>
+                    </a:lnR>
+                    <a:lnT w="0" cap="flat" cmpd="sng" algn="ctr">
+                      <a:noFill/>
+                    </a:lnT>
+                    <a:lnB w="6350" cap="flat" cmpd="sng" algn="ctr">
+                      <a:solidFill>
+                        <a:srgbClr val="D3C9BA"/>
+                      </a:solidFill>
+                      <a:prstDash val="solid"/>
+                      <a:round/>
+                      <a:headEnd type="none" w="med" len="med"/>
+                      <a:tailEnd type="none" w="med" len="med"/>
+                    </a:lnB>
+                  </a:tcPr>
+                </a:tc>
+                <a:tc>
+                  <a:txBody>
+                    <a:bodyPr/>
+                    <a:lstStyle/>
+                    <a:p>
+                      <a:pPr algn="r" indent="0" marL="0">
+                        <a:buNone/>
+                      </a:pPr>
+                      <a:r>
+                        <a:rPr lang="en-US" sz="1250" dirty="0">
+                          <a:solidFill>
+                            <a:srgbClr val="201E1D"/>
+                          </a:solidFill>
+                          <a:latin typeface="Nunito" pitchFamily="34" charset="0"/>
+                          <a:ea typeface="Nunito" pitchFamily="34" charset="-122"/>
+                          <a:cs typeface="Nunito" pitchFamily="34" charset="-120"/>
+                        </a:rPr>
+                        <a:t>31,99</a:t>
+                      </a:r>
+                      <a:endParaRPr lang="en-US" sz="1250" dirty="0">
+                        <a:latin typeface="Nunito" charset="0"/>
+                        <a:ea typeface="Nunito" charset="0"/>
+                        <a:cs typeface="Nunito" charset="0"/>
+                      </a:endParaRPr>
+                    </a:p>
+                  </a:txBody>
+                  <a:tcPr marL="0" marR="76200" marT="38100" marB="38100" anchor="ctr">
+                    <a:lnL w="0" cap="flat" cmpd="sng" algn="ctr">
+                      <a:noFill/>
+                    </a:lnL>
+                    <a:lnR w="0" cap="flat" cmpd="sng" algn="ctr">
+                      <a:noFill/>
+                    </a:lnR>
+                    <a:lnT w="0" cap="flat" cmpd="sng" algn="ctr">
+                      <a:noFill/>
+                    </a:lnT>
+                    <a:lnB w="6350" cap="flat" cmpd="sng" algn="ctr">
+                      <a:solidFill>
+                        <a:srgbClr val="D3C9BA"/>
+                      </a:solidFill>
+                      <a:prstDash val="solid"/>
+                      <a:round/>
+                      <a:headEnd type="none" w="med" len="med"/>
+                      <a:tailEnd type="none" w="med" len="med"/>
+                    </a:lnB>
+                  </a:tcPr>
+                </a:tc>
+                <a:tc>
+                  <a:txBody>
+                    <a:bodyPr/>
+                    <a:lstStyle/>
+                    <a:p>
+                      <a:pPr algn="r" indent="0" marL="0">
+                        <a:buNone/>
+                      </a:pPr>
+                      <a:r>
+                        <a:rPr lang="en-US" sz="1250" dirty="0">
+                          <a:solidFill>
+                            <a:srgbClr val="201E1D"/>
+                          </a:solidFill>
+                          <a:latin typeface="Nunito" pitchFamily="34" charset="0"/>
+                          <a:ea typeface="Nunito" pitchFamily="34" charset="-122"/>
+                          <a:cs typeface="Nunito" pitchFamily="34" charset="-120"/>
+                        </a:rPr>
+                        <a:t>30,53–33,49</a:t>
+                      </a:r>
+                      <a:endParaRPr lang="en-US" sz="1250" dirty="0">
+                        <a:latin typeface="Nunito" charset="0"/>
+                        <a:ea typeface="Nunito" charset="0"/>
+                        <a:cs typeface="Nunito" charset="0"/>
+                      </a:endParaRPr>
+                    </a:p>
+                  </a:txBody>
+                  <a:tcPr marL="0" marR="76200" marT="38100" marB="38100" anchor="ctr">
+                    <a:lnL w="0" cap="flat" cmpd="sng" algn="ctr">
+                      <a:noFill/>
+                    </a:lnL>
+                    <a:lnR w="0" cap="flat" cmpd="sng" algn="ctr">
+                      <a:noFill/>
+                    </a:lnR>
+                    <a:lnT w="0" cap="flat" cmpd="sng" algn="ctr">
+                      <a:noFill/>
+                    </a:lnT>
+                    <a:lnB w="6350" cap="flat" cmpd="sng" algn="ctr">
+                      <a:solidFill>
+                        <a:srgbClr val="D3C9BA"/>
+                      </a:solidFill>
+                      <a:prstDash val="solid"/>
+                      <a:round/>
+                      <a:headEnd type="none" w="med" len="med"/>
+                      <a:tailEnd type="none" w="med" len="med"/>
+                    </a:lnB>
+                  </a:tcPr>
+                </a:tc>
+                <a:tc>
+                  <a:txBody>
+                    <a:bodyPr/>
+                    <a:lstStyle/>
+                    <a:p>
+                      <a:pPr algn="r" indent="0" marL="0">
+                        <a:buNone/>
+                      </a:pPr>
+                      <a:r>
+                        <a:rPr lang="en-US" sz="1250" dirty="0">
+                          <a:solidFill>
+                            <a:srgbClr val="201E1D"/>
+                          </a:solidFill>
+                          <a:latin typeface="Nunito" pitchFamily="34" charset="0"/>
+                          <a:ea typeface="Nunito" pitchFamily="34" charset="-122"/>
+                          <a:cs typeface="Nunito" pitchFamily="34" charset="-120"/>
+                        </a:rPr>
+                        <a:t>34,66</a:t>
+                      </a:r>
+                      <a:endParaRPr lang="en-US" sz="1250" dirty="0">
+                        <a:latin typeface="Nunito" charset="0"/>
+                        <a:ea typeface="Nunito" charset="0"/>
+                        <a:cs typeface="Nunito" charset="0"/>
+                      </a:endParaRPr>
+                    </a:p>
+                  </a:txBody>
+                  <a:tcPr marL="0" marR="76200" marT="38100" marB="38100" anchor="ctr">
+                    <a:lnL w="0" cap="flat" cmpd="sng" algn="ctr">
+                      <a:noFill/>
+                    </a:lnL>
+                    <a:lnR w="0" cap="flat" cmpd="sng" algn="ctr">
+                      <a:noFill/>
+                    </a:lnR>
+                    <a:lnT w="0" cap="flat" cmpd="sng" algn="ctr">
+                      <a:noFill/>
+                    </a:lnT>
+                    <a:lnB w="6350" cap="flat" cmpd="sng" algn="ctr">
+                      <a:solidFill>
+                        <a:srgbClr val="D3C9BA"/>
+                      </a:solidFill>
+                      <a:prstDash val="solid"/>
+                      <a:round/>
+                      <a:headEnd type="none" w="med" len="med"/>
+                      <a:tailEnd type="none" w="med" len="med"/>
+                    </a:lnB>
+                  </a:tcPr>
+                </a:tc>
+              </a:tr>
+              <a:tr h="329184">
+                <a:tc>
+                  <a:txBody>
+                    <a:bodyPr/>
+                    <a:lstStyle/>
+                    <a:p>
+                      <a:pPr algn="l" indent="0" marL="0">
+                        <a:buNone/>
+                      </a:pPr>
+                      <a:r>
+                        <a:rPr lang="en-US" sz="1250" dirty="0">
+                          <a:solidFill>
+                            <a:srgbClr val="201E1D"/>
+                          </a:solidFill>
+                          <a:latin typeface="Nunito" pitchFamily="34" charset="0"/>
+                          <a:ea typeface="Nunito" pitchFamily="34" charset="-122"/>
+                          <a:cs typeface="Nunito" pitchFamily="34" charset="-120"/>
+                        </a:rPr>
+                        <a:t>mbert</a:t>
+                      </a:r>
+                      <a:endParaRPr lang="en-US" sz="1250" dirty="0">
+                        <a:latin typeface="Nunito" charset="0"/>
+                        <a:ea typeface="Nunito" charset="0"/>
+                        <a:cs typeface="Nunito" charset="0"/>
+                      </a:endParaRPr>
+                    </a:p>
+                  </a:txBody>
+                  <a:tcPr marL="0" marR="76200" marT="38100" marB="38100" anchor="ctr">
+                    <a:lnL w="0" cap="flat" cmpd="sng" algn="ctr">
+                      <a:noFill/>
+                    </a:lnL>
+                    <a:lnR w="0" cap="flat" cmpd="sng" algn="ctr">
+                      <a:noFill/>
+                    </a:lnR>
+                    <a:lnT w="0" cap="flat" cmpd="sng" algn="ctr">
+                      <a:noFill/>
+                    </a:lnT>
+                    <a:lnB w="6350" cap="flat" cmpd="sng" algn="ctr">
+                      <a:solidFill>
+                        <a:srgbClr val="D3C9BA"/>
+                      </a:solidFill>
+                      <a:prstDash val="solid"/>
+                      <a:round/>
+                      <a:headEnd type="none" w="med" len="med"/>
+                      <a:tailEnd type="none" w="med" len="med"/>
+                    </a:lnB>
+                  </a:tcPr>
+                </a:tc>
+                <a:tc>
+                  <a:txBody>
+                    <a:bodyPr/>
+                    <a:lstStyle/>
+                    <a:p>
+                      <a:pPr algn="r" indent="0" marL="0">
+                        <a:buNone/>
+                      </a:pPr>
+                      <a:r>
+                        <a:rPr lang="en-US" sz="1250" dirty="0">
+                          <a:solidFill>
+                            <a:srgbClr val="201E1D"/>
+                          </a:solidFill>
+                          <a:latin typeface="Nunito" pitchFamily="34" charset="0"/>
+                          <a:ea typeface="Nunito" pitchFamily="34" charset="-122"/>
+                          <a:cs typeface="Nunito" pitchFamily="34" charset="-120"/>
+                        </a:rPr>
+                        <a:t>48,95</a:t>
+                      </a:r>
+                      <a:endParaRPr lang="en-US" sz="1250" dirty="0">
+                        <a:latin typeface="Nunito" charset="0"/>
+                        <a:ea typeface="Nunito" charset="0"/>
+                        <a:cs typeface="Nunito" charset="0"/>
+                      </a:endParaRPr>
+                    </a:p>
+                  </a:txBody>
+                  <a:tcPr marL="0" marR="76200" marT="38100" marB="38100" anchor="ctr">
+                    <a:lnL w="0" cap="flat" cmpd="sng" algn="ctr">
+                      <a:noFill/>
+                    </a:lnL>
+                    <a:lnR w="0" cap="flat" cmpd="sng" algn="ctr">
+                      <a:noFill/>
+                    </a:lnR>
+                    <a:lnT w="0" cap="flat" cmpd="sng" algn="ctr">
+                      <a:noFill/>
+                    </a:lnT>
+                    <a:lnB w="6350" cap="flat" cmpd="sng" algn="ctr">
+                      <a:solidFill>
+                        <a:srgbClr val="D3C9BA"/>
+                      </a:solidFill>
+                      <a:prstDash val="solid"/>
+                      <a:round/>
+                      <a:headEnd type="none" w="med" len="med"/>
+                      <a:tailEnd type="none" w="med" len="med"/>
+                    </a:lnB>
+                  </a:tcPr>
+                </a:tc>
+                <a:tc>
+                  <a:txBody>
+                    <a:bodyPr/>
+                    <a:lstStyle/>
+                    <a:p>
+                      <a:pPr algn="r" indent="0" marL="0">
+                        <a:buNone/>
+                      </a:pPr>
+                      <a:r>
+                        <a:rPr lang="en-US" sz="1250" dirty="0">
+                          <a:solidFill>
+                            <a:srgbClr val="201E1D"/>
+                          </a:solidFill>
+                          <a:latin typeface="Nunito" pitchFamily="34" charset="0"/>
+                          <a:ea typeface="Nunito" pitchFamily="34" charset="-122"/>
+                          <a:cs typeface="Nunito" pitchFamily="34" charset="-120"/>
+                        </a:rPr>
+                        <a:t>47,37–50,54</a:t>
+                      </a:r>
+                      <a:endParaRPr lang="en-US" sz="1250" dirty="0">
+                        <a:latin typeface="Nunito" charset="0"/>
+                        <a:ea typeface="Nunito" charset="0"/>
+                        <a:cs typeface="Nunito" charset="0"/>
+                      </a:endParaRPr>
+                    </a:p>
+                  </a:txBody>
+                  <a:tcPr marL="0" marR="76200" marT="38100" marB="38100" anchor="ctr">
+                    <a:lnL w="0" cap="flat" cmpd="sng" algn="ctr">
+                      <a:noFill/>
+                    </a:lnL>
+                    <a:lnR w="0" cap="flat" cmpd="sng" algn="ctr">
+                      <a:noFill/>
+                    </a:lnR>
+                    <a:lnT w="0" cap="flat" cmpd="sng" algn="ctr">
+                      <a:noFill/>
+                    </a:lnT>
+                    <a:lnB w="6350" cap="flat" cmpd="sng" algn="ctr">
+                      <a:solidFill>
+                        <a:srgbClr val="D3C9BA"/>
+                      </a:solidFill>
+                      <a:prstDash val="solid"/>
+                      <a:round/>
+                      <a:headEnd type="none" w="med" len="med"/>
+                      <a:tailEnd type="none" w="med" len="med"/>
+                    </a:lnB>
+                  </a:tcPr>
+                </a:tc>
+                <a:tc>
+                  <a:txBody>
+                    <a:bodyPr/>
+                    <a:lstStyle/>
+                    <a:p>
+                      <a:pPr algn="r" indent="0" marL="0">
+                        <a:buNone/>
+                      </a:pPr>
+                      <a:r>
+                        <a:rPr lang="en-US" sz="1250" dirty="0">
+                          <a:solidFill>
+                            <a:srgbClr val="201E1D"/>
+                          </a:solidFill>
+                          <a:latin typeface="Nunito" pitchFamily="34" charset="0"/>
+                          <a:ea typeface="Nunito" pitchFamily="34" charset="-122"/>
+                          <a:cs typeface="Nunito" pitchFamily="34" charset="-120"/>
+                        </a:rPr>
+                        <a:t>57,98</a:t>
+                      </a:r>
+                      <a:endParaRPr lang="en-US" sz="1250" dirty="0">
+                        <a:latin typeface="Nunito" charset="0"/>
+                        <a:ea typeface="Nunito" charset="0"/>
+                        <a:cs typeface="Nunito" charset="0"/>
+                      </a:endParaRPr>
+                    </a:p>
+                  </a:txBody>
+                  <a:tcPr marL="0" marR="76200" marT="38100" marB="38100" anchor="ctr">
+                    <a:lnL w="0" cap="flat" cmpd="sng" algn="ctr">
+                      <a:noFill/>
+                    </a:lnL>
+                    <a:lnR w="0" cap="flat" cmpd="sng" algn="ctr">
+                      <a:noFill/>
+                    </a:lnR>
+                    <a:lnT w="0" cap="flat" cmpd="sng" algn="ctr">
+                      <a:noFill/>
+                    </a:lnT>
+                    <a:lnB w="6350" cap="flat" cmpd="sng" algn="ctr">
+                      <a:solidFill>
+                        <a:srgbClr val="D3C9BA"/>
+                      </a:solidFill>
+                      <a:prstDash val="solid"/>
+                      <a:round/>
+                      <a:headEnd type="none" w="med" len="med"/>
+                      <a:tailEnd type="none" w="med" len="med"/>
+                    </a:lnB>
+                  </a:tcPr>
+                </a:tc>
+              </a:tr>
+            </a:tbl>
+          </a:graphicData>
+        </a:graphic>
+      </p:graphicFrame>
+      <p:sp>
+        <p:nvSpPr>
+          <p:cNvPr id="5" name="Text 2"/>
+          <p:cNvSpPr txBox="1"/>
+          <p:nvPr/>
+        </p:nvSpPr>
+        <p:spPr>
+          <a:xfrm>
+            <a:off x="6858000" y="1737360"/>
+            <a:ext cx="4572000" cy="1280160"/>
+          </a:xfrm>
+          <a:prstGeom prst="rect">
+            <a:avLst/>
+          </a:prstGeom>
+          <a:noFill/>
+          <a:ln/>
+        </p:spPr>
+        <p:txBody>
+          <a:bodyPr wrap="square" lIns="0" tIns="0" rIns="0" bIns="0" rtlCol="0" anchor="t"/>
+          <a:lstStyle/>
+          <a:p>
+            <a:pPr algn="l" indent="0" marL="0">
+              <a:lnSpc>
+                <a:spcPts val="1740"/>
+              </a:lnSpc>
+              <a:buNone/>
+            </a:pPr>
+            <a:r>
+              <a:rPr lang="en-US" sz="1200" dirty="0">
+                <a:solidFill>
+                  <a:srgbClr val="645C50"/>
+                </a:solidFill>
+                <a:latin typeface="Nunito" pitchFamily="34" charset="0"/>
+                <a:ea typeface="Nunito" pitchFamily="34" charset="-122"/>
+                <a:cs typeface="Nunito" pitchFamily="34" charset="-120"/>
+              </a:rPr>
+              <a:t>mBERT vs XLM-R: ΔEM = 9,73 (bootstrap cụm đoạn văn 95% CI [8,09, 11,46]); McNemar p = 0.0000</a:t>
+            </a:r>
+            <a:endParaRPr lang="en-US" sz="1200" dirty="0"/>
+          </a:p>
+        </p:txBody>
+      </p:sp>
+      <p:sp>
+        <p:nvSpPr>
+          <p:cNvPr id="6" name="Text 3"/>
+          <p:cNvSpPr txBox="1"/>
+          <p:nvPr/>
+        </p:nvSpPr>
+        <p:spPr>
+          <a:xfrm>
+            <a:off x="685800" y="6327648"/>
+            <a:ext cx="10271455" cy="274320"/>
+          </a:xfrm>
+          <a:prstGeom prst="rect">
+            <a:avLst/>
+          </a:prstGeom>
+          <a:noFill/>
+          <a:ln/>
+        </p:spPr>
+        <p:txBody>
+          <a:bodyPr wrap="square" lIns="0" tIns="0" rIns="0" bIns="0" rtlCol="0" anchor="ctr"/>
+          <a:lstStyle/>
+          <a:p>
+            <a:pPr indent="0" marL="0">
+              <a:buNone/>
+            </a:pPr>
+            <a:r>
+              <a:rPr lang="en-US" sz="1000" dirty="0">
+                <a:solidFill>
+                  <a:srgbClr val="645C50"/>
+                </a:solidFill>
+                <a:latin typeface="Nunito" pitchFamily="34" charset="0"/>
+                <a:ea typeface="Nunito" pitchFamily="34" charset="-122"/>
+                <a:cs typeface="Nunito" pitchFamily="34" charset="-120"/>
+              </a:rPr>
+              <a:t>Phụ lục · P2 · Wilson &amp; McNemar</a:t>
+            </a:r>
+            <a:endParaRPr lang="en-US" sz="1000" dirty="0"/>
+          </a:p>
+        </p:txBody>
+      </p:sp>
+      <p:sp>
+        <p:nvSpPr>
+          <p:cNvPr id="7" name="Text 4"/>
+          <p:cNvSpPr txBox="1"/>
+          <p:nvPr/>
+        </p:nvSpPr>
+        <p:spPr>
+          <a:xfrm>
+            <a:off x="10957255" y="6327648"/>
+            <a:ext cx="548640" cy="274320"/>
+          </a:xfrm>
+          <a:prstGeom prst="rect">
+            <a:avLst/>
+          </a:prstGeom>
+          <a:noFill/>
+          <a:ln/>
+        </p:spPr>
+        <p:txBody>
+          <a:bodyPr wrap="square" lIns="0" tIns="0" rIns="0" bIns="0" rtlCol="0" anchor="ctr"/>
+          <a:lstStyle/>
+          <a:p>
+            <a:pPr algn="r" indent="0" marL="0">
+              <a:buNone/>
+            </a:pPr>
+            <a:r>
+              <a:rPr lang="en-US" sz="1000" dirty="0">
+                <a:solidFill>
+                  <a:srgbClr val="645C50"/>
+                </a:solidFill>
+                <a:latin typeface="Nunito" pitchFamily="34" charset="0"/>
+                <a:ea typeface="Nunito" pitchFamily="34" charset="-122"/>
+                <a:cs typeface="Nunito" pitchFamily="34" charset="-120"/>
+              </a:rPr>
+              <a:t>22</a:t>
             </a:r>
             <a:endParaRPr lang="en-US" sz="1000" dirty="0"/>
           </a:p>
@@ -31352,7 +32656,7 @@
                           <a:ea typeface="Nunito" pitchFamily="34" charset="-122"/>
                           <a:cs typeface="Nunito" pitchFamily="34" charset="-120"/>
                         </a:rPr>
-                        <a:t>mẫu đánh giá 500 câu</a:t>
+                        <a:t>mẫu đánh giá 3814 câu</a:t>
                       </a:r>
                       <a:endParaRPr lang="en-US" sz="1100" dirty="0">
                         <a:latin typeface="Nunito" charset="0"/>
@@ -31399,7 +32703,7 @@
                           <a:ea typeface="Nunito" pitchFamily="34" charset="-122"/>
                           <a:cs typeface="Nunito" pitchFamily="34" charset="-120"/>
                         </a:rPr>
-                        <a:t>139 / 500</a:t>
+                        <a:t>1161 / 3814</a:t>
                       </a:r>
                       <a:endParaRPr lang="en-US" sz="1100" dirty="0">
                         <a:latin typeface="Nunito" charset="0"/>
@@ -31446,7 +32750,7 @@
                           <a:ea typeface="Nunito" pitchFamily="34" charset="-122"/>
                           <a:cs typeface="Nunito" pitchFamily="34" charset="-120"/>
                         </a:rPr>
-                        <a:t>27,80%</a:t>
+                        <a:t>30,44%</a:t>
                       </a:r>
                       <a:endParaRPr lang="en-US" sz="1100" dirty="0">
                         <a:latin typeface="Nunito" charset="0"/>
@@ -32417,7 +33721,7 @@
                 <a:ea typeface="Nunito" pitchFamily="34" charset="-122"/>
                 <a:cs typeface="Nunito" pitchFamily="34" charset="-120"/>
               </a:rPr>
-              <a:t>MẪU ĐÁNH GIÁ 500 CÂU THEO NHÓM ĐỘ DÀI ĐOẠN VĂN — NGUỒN: RESULTS/EVAL_*.JSON</a:t>
+              <a:t>MẪU ĐÁNH GIÁ 3814 CÂU THEO NHÓM ĐỘ DÀI ĐOẠN VĂN — NGUỒN: RESULTS/EVAL_*.JSON</a:t>
             </a:r>
             <a:endParaRPr lang="en-US" sz="950" dirty="0"/>
           </a:p>
@@ -32456,7 +33760,7 @@
                 <a:ea typeface="Baloo 2" pitchFamily="34" charset="-122"/>
                 <a:cs typeface="Baloo 2" pitchFamily="34" charset="-120"/>
               </a:rPr>
-              <a:t>1</a:t>
+              <a:t>10</a:t>
             </a:r>
             <a:pPr indent="0" marL="0">
               <a:buNone/>
@@ -32551,7 +33855,7 @@
                 <a:ea typeface="Baloo 2" pitchFamily="34" charset="-122"/>
                 <a:cs typeface="Baloo 2" pitchFamily="34" charset="-120"/>
               </a:rPr>
-              <a:t>405</a:t>
+              <a:t>2982</a:t>
             </a:r>
             <a:pPr indent="0" marL="0">
               <a:buNone/>
@@ -32646,7 +33950,7 @@
                 <a:ea typeface="Baloo 2" pitchFamily="34" charset="-122"/>
                 <a:cs typeface="Baloo 2" pitchFamily="34" charset="-120"/>
               </a:rPr>
-              <a:t>85</a:t>
+              <a:t>693</a:t>
             </a:r>
             <a:pPr indent="0" marL="0">
               <a:buNone/>
@@ -32735,13 +34039,13 @@
             <a:r>
               <a:rPr lang="en-US" sz="2600" b="1" dirty="0">
                 <a:solidFill>
-                  <a:srgbClr val="645C50"/>
+                  <a:srgbClr val="C67139"/>
                 </a:solidFill>
                 <a:latin typeface="Baloo 2" pitchFamily="34" charset="0"/>
                 <a:ea typeface="Baloo 2" pitchFamily="34" charset="-122"/>
                 <a:cs typeface="Baloo 2" pitchFamily="34" charset="-120"/>
               </a:rPr>
-              <a:t>9</a:t>
+              <a:t>129</a:t>
             </a:r>
             <a:pPr indent="0" marL="0">
               <a:buNone/>
@@ -32797,7 +34101,7 @@
                 <a:ea typeface="Nunito" pitchFamily="34" charset="-122"/>
                 <a:cs typeface="Nunito" pitchFamily="34" charset="-120"/>
               </a:rPr>
-              <a:t>300+ từ · n &lt; 30 ⇒ cờ unreliable</a:t>
+              <a:t>300+ từ</a:t>
             </a:r>
             <a:endParaRPr lang="en-US" sz="1150" dirty="0"/>
           </a:p>
@@ -32908,7 +34212,7 @@
                 <a:ea typeface="Nunito" pitchFamily="34" charset="-122"/>
                 <a:cs typeface="Nunito" pitchFamily="34" charset="-120"/>
               </a:rPr>
-              <a:t>Một: mẫu 500 câu gần như không có đoạn dài (9 câu ở nhóm 300+), nên câu hỏi “độ dài context ảnh hưởng thế nào” CHƯA được trả lời — nhóm ghi vào phần hạn chế. Hai: đuôi dài của đáp án là lý do L_max phải đặt theo tokenizer.</a:t>
+              <a:t>Một: mẫu 3814 câu gần như không có đoạn dài (129 câu ở nhóm 300+), nên câu hỏi “độ dài context ảnh hưởng thế nào” CHƯA được trả lời — nhóm ghi vào phần hạn chế. Hai: đuôi dài của đáp án là lý do L_max phải đặt theo tokenizer.</a:t>
             </a:r>
             <a:endParaRPr lang="en-US" sz="1150" dirty="0"/>
           </a:p>
@@ -35011,7 +36315,7 @@
                 <a:ea typeface="Nunito" pitchFamily="34" charset="-122"/>
                 <a:cs typeface="Nunito" pitchFamily="34" charset="-120"/>
               </a:rPr>
-              <a:t>Mẫu 500 câu phủ 19/19 bài viết, 5 bài lớn nhất chiếm 57,0% so với 53,1% của toàn tập: mẫu đại diện được về chủ đề. Cùng hàm lấy mẫu dùng cho cả đường cong huấn luyện và bảng kết quả cuối, nên hai nguồn số liệu so sánh được với nhau.</a:t>
+              <a:t>Mẫu 3814 câu phủ 19/19 bài viết, 5 bài lớn nhất chiếm 57,0% so với 53,1% của toàn tập: mẫu đại diện được về chủ đề. Cùng hàm lấy mẫu dùng cho cả đường cong huấn luyện và bảng kết quả cuối, nên hai nguồn số liệu so sánh được với nhau.</a:t>
             </a:r>
             <a:endParaRPr lang="en-US" sz="1150" dirty="0"/>
           </a:p>

</xml_diff>